<commit_message>
examples: fix 05_space_aware fit_text demo so the size difference is visible
The left "naive Pt(36)" box was inheriting add_textbox's default
auto_size=SHAPE_TO_FIT_TEXT and silently growing to fit, and font
size was being set on the paragraph (no run yet) instead of the run
itself, so it never actually applied. Both boxes ended up rendering
identically — the demo wasn't showing anything.

Fix: pin auto_size=NONE on the naive box, style the runs explicitly,
and tighten the box height to 2.0 inches so 36pt visibly overflows
and fit_text has to drop the size to 30pt to make it fit. The
6pt difference is now obvious at a glance.

https://claude.ai/code/session_01TTPAcGiq4DL9nzBGng94Pt
</commit_message>
<xml_diff>
--- a/examples/showcase/_out/05_space_aware.pptx
+++ b/examples/showcase/_out/05_space_aware.pptx
@@ -3175,7 +3175,7 @@
         <p:spPr>
           <a:xfrm>
             <a:off x="548640" y="1920240"/>
-            <a:ext cx="5486400" cy="2743200"/>
+            <a:ext cx="5486400" cy="1828800"/>
           </a:xfrm>
           <a:prstGeom prst="rect">
             <a:avLst/>
@@ -3198,18 +3198,17 @@
         </p:spPr>
         <p:txBody>
           <a:bodyPr wrap="square" lIns="177800" rIns="177800" tIns="177800" bIns="177800">
-            <a:spAutoFit/>
+            <a:noAutofit/>
           </a:bodyPr>
           <a:lstStyle/>
           <a:p>
-            <a:pPr>
-              <a:defRPr sz="3600" b="1">
+            <a:r>
+              <a:rPr sz="3600" b="1">
                 <a:solidFill>
                   <a:srgbClr val="0F172A"/>
                 </a:solidFill>
-              </a:defRPr>
-            </a:pPr>
-            <a:r>
+                <a:latin typeface="Inter"/>
+              </a:rPr>
               <a:t>Q4 2026 Customer Outcomes Review — flagship rollouts, expansion bookings, and headline retention metrics</a:t>
             </a:r>
           </a:p>
@@ -3223,7 +3222,7 @@
         </p:nvSpPr>
         <p:spPr>
           <a:xfrm>
-            <a:off x="548640" y="4937760"/>
+            <a:off x="548640" y="4023360"/>
             <a:ext cx="5486400" cy="365760"/>
           </a:xfrm>
           <a:prstGeom prst="rect">
@@ -3259,7 +3258,7 @@
         <p:spPr>
           <a:xfrm>
             <a:off x="6126480" y="1920240"/>
-            <a:ext cx="5486400" cy="2743200"/>
+            <a:ext cx="5486400" cy="1828800"/>
           </a:xfrm>
           <a:prstGeom prst="rect">
             <a:avLst/>
@@ -3286,20 +3285,16 @@
           </a:bodyPr>
           <a:lstStyle/>
           <a:p>
-            <a:pPr>
-              <a:defRPr>
+            <a:r>
+              <a:rPr sz="3000" b="1" i="0">
                 <a:solidFill>
                   <a:srgbClr val="0F172A"/>
                 </a:solidFill>
-              </a:defRPr>
-            </a:pPr>
-            <a:r>
-              <a:rPr sz="3500" b="1" i="0">
                 <a:latin typeface="Inter"/>
               </a:rPr>
               <a:t>Q4 2026 Customer Outcomes Review — flagship rollouts, expansion bookings, and headline retention metrics</a:t>
             </a:r>
-            <a:endParaRPr sz="3500" b="1" i="0">
+            <a:endParaRPr sz="3000" b="1" i="0">
               <a:latin typeface="Inter"/>
             </a:endParaRPr>
           </a:p>
@@ -3313,7 +3308,7 @@
         </p:nvSpPr>
         <p:spPr>
           <a:xfrm>
-            <a:off x="6126480" y="4937760"/>
+            <a:off x="6126480" y="4023360"/>
             <a:ext cx="5486400" cy="365760"/>
           </a:xfrm>
           <a:prstGeom prst="rect">

</xml_diff>